<commit_message>
Design the opening luggage-tag puzzle; add postcard 01's Fun Fact block
Opening puzzle (PC-01): two fictional hotel luggage tags, each carrying
a printed "if found" line Liv never filled in and a hand-written hotel
address instead. The street number is the only number on each tag and
doubles as half the four-digit code (1021, the tree-ring date for the
Norse at L'Anse aux Meadows). Adds the insert-card print master and
resolves PR-01's buy-check against a candidate real luggage tag.

Also folds in this session's postcard-system pass from earlier work:
postcard 01 now carries its typed Fun Fact block (real trivia, per the
Postcard system tab's four-zone spec), with the address block resized
to make room and the PDFs/PNG regenerated to match.

Co-Authored-By: Claude Sonnet 5 <noreply@anthropic.com>
</commit_message>
<xml_diff>
--- a/NorseBackpack/Norse_Ideas.pptx
+++ b/NorseBackpack/Norse_Ideas.pptx
@@ -5,13 +5,14 @@
     <p:sldMasterId id="2147483648" r:id="rId1"/>
   </p:sldMasterIdLst>
   <p:notesMasterIdLst>
-    <p:notesMasterId r:id="rId6"/>
+    <p:notesMasterId r:id="rId7"/>
   </p:notesMasterIdLst>
   <p:sldIdLst>
     <p:sldId id="256" r:id="rId2"/>
     <p:sldId id="259" r:id="rId3"/>
     <p:sldId id="261" r:id="rId4"/>
     <p:sldId id="260" r:id="rId5"/>
+    <p:sldId id="262" r:id="rId6"/>
   </p:sldIdLst>
   <p:sldSz cx="12192000" cy="6858000"/>
   <p:notesSz cx="6858000" cy="9144000"/>
@@ -1224,7 +1225,7 @@
           <a:p>
             <a:fld id="{08C6FC6E-B707-4490-8CD6-BC620120533F}" type="datetimeFigureOut">
               <a:rPr lang="en-CA" smtClean="0"/>
-              <a:t>2026-05-01</a:t>
+              <a:t>2026-09-11</a:t>
             </a:fld>
             <a:endParaRPr lang="en-CA"/>
           </a:p>
@@ -1641,7 +1642,7 @@
           <a:p>
             <a:fld id="{DDEFC1D5-8823-4690-A09A-C7DCA957B2C3}" type="datetimeFigureOut">
               <a:rPr lang="en-CA" smtClean="0"/>
-              <a:t>2026-05-01</a:t>
+              <a:t>2026-09-11</a:t>
             </a:fld>
             <a:endParaRPr lang="en-CA"/>
           </a:p>
@@ -1841,7 +1842,7 @@
           <a:p>
             <a:fld id="{DDEFC1D5-8823-4690-A09A-C7DCA957B2C3}" type="datetimeFigureOut">
               <a:rPr lang="en-CA" smtClean="0"/>
-              <a:t>2026-05-01</a:t>
+              <a:t>2026-09-11</a:t>
             </a:fld>
             <a:endParaRPr lang="en-CA"/>
           </a:p>
@@ -2051,7 +2052,7 @@
           <a:p>
             <a:fld id="{DDEFC1D5-8823-4690-A09A-C7DCA957B2C3}" type="datetimeFigureOut">
               <a:rPr lang="en-CA" smtClean="0"/>
-              <a:t>2026-05-01</a:t>
+              <a:t>2026-09-11</a:t>
             </a:fld>
             <a:endParaRPr lang="en-CA"/>
           </a:p>
@@ -2251,7 +2252,7 @@
           <a:p>
             <a:fld id="{DDEFC1D5-8823-4690-A09A-C7DCA957B2C3}" type="datetimeFigureOut">
               <a:rPr lang="en-CA" smtClean="0"/>
-              <a:t>2026-05-01</a:t>
+              <a:t>2026-09-11</a:t>
             </a:fld>
             <a:endParaRPr lang="en-CA"/>
           </a:p>
@@ -2527,7 +2528,7 @@
           <a:p>
             <a:fld id="{DDEFC1D5-8823-4690-A09A-C7DCA957B2C3}" type="datetimeFigureOut">
               <a:rPr lang="en-CA" smtClean="0"/>
-              <a:t>2026-05-01</a:t>
+              <a:t>2026-09-11</a:t>
             </a:fld>
             <a:endParaRPr lang="en-CA"/>
           </a:p>
@@ -2795,7 +2796,7 @@
           <a:p>
             <a:fld id="{DDEFC1D5-8823-4690-A09A-C7DCA957B2C3}" type="datetimeFigureOut">
               <a:rPr lang="en-CA" smtClean="0"/>
-              <a:t>2026-05-01</a:t>
+              <a:t>2026-09-11</a:t>
             </a:fld>
             <a:endParaRPr lang="en-CA"/>
           </a:p>
@@ -3210,7 +3211,7 @@
           <a:p>
             <a:fld id="{DDEFC1D5-8823-4690-A09A-C7DCA957B2C3}" type="datetimeFigureOut">
               <a:rPr lang="en-CA" smtClean="0"/>
-              <a:t>2026-05-01</a:t>
+              <a:t>2026-09-11</a:t>
             </a:fld>
             <a:endParaRPr lang="en-CA"/>
           </a:p>
@@ -3352,7 +3353,7 @@
           <a:p>
             <a:fld id="{DDEFC1D5-8823-4690-A09A-C7DCA957B2C3}" type="datetimeFigureOut">
               <a:rPr lang="en-CA" smtClean="0"/>
-              <a:t>2026-05-01</a:t>
+              <a:t>2026-09-11</a:t>
             </a:fld>
             <a:endParaRPr lang="en-CA"/>
           </a:p>
@@ -3465,7 +3466,7 @@
           <a:p>
             <a:fld id="{DDEFC1D5-8823-4690-A09A-C7DCA957B2C3}" type="datetimeFigureOut">
               <a:rPr lang="en-CA" smtClean="0"/>
-              <a:t>2026-05-01</a:t>
+              <a:t>2026-09-11</a:t>
             </a:fld>
             <a:endParaRPr lang="en-CA"/>
           </a:p>
@@ -3778,7 +3779,7 @@
           <a:p>
             <a:fld id="{DDEFC1D5-8823-4690-A09A-C7DCA957B2C3}" type="datetimeFigureOut">
               <a:rPr lang="en-CA" smtClean="0"/>
-              <a:t>2026-05-01</a:t>
+              <a:t>2026-09-11</a:t>
             </a:fld>
             <a:endParaRPr lang="en-CA"/>
           </a:p>
@@ -4067,7 +4068,7 @@
           <a:p>
             <a:fld id="{DDEFC1D5-8823-4690-A09A-C7DCA957B2C3}" type="datetimeFigureOut">
               <a:rPr lang="en-CA" smtClean="0"/>
-              <a:t>2026-05-01</a:t>
+              <a:t>2026-09-11</a:t>
             </a:fld>
             <a:endParaRPr lang="en-CA"/>
           </a:p>
@@ -4310,7 +4311,7 @@
           <a:p>
             <a:fld id="{DDEFC1D5-8823-4690-A09A-C7DCA957B2C3}" type="datetimeFigureOut">
               <a:rPr lang="en-CA" smtClean="0"/>
-              <a:t>2026-05-01</a:t>
+              <a:t>2026-09-11</a:t>
             </a:fld>
             <a:endParaRPr lang="en-CA"/>
           </a:p>
@@ -5494,6 +5495,412 @@
     <p:extLst>
       <p:ext uri="{BB962C8B-B14F-4D97-AF65-F5344CB8AC3E}">
         <p14:creationId xmlns:p14="http://schemas.microsoft.com/office/powerpoint/2010/main" val="781780858"/>
+      </p:ext>
+    </p:extLst>
+  </p:cSld>
+  <p:clrMapOvr>
+    <a:masterClrMapping/>
+  </p:clrMapOvr>
+</p:sld>
+</file>
+
+<file path=ppt/slides/slide5.xml><?xml version="1.0" encoding="utf-8"?>
+<p:sld xmlns:a="http://schemas.openxmlformats.org/drawingml/2006/main" xmlns:r="http://schemas.openxmlformats.org/officeDocument/2006/relationships" xmlns:p="http://schemas.openxmlformats.org/presentationml/2006/main">
+  <p:cSld>
+    <p:bg>
+      <p:bgPr>
+        <a:solidFill>
+          <a:schemeClr val="tx2">
+            <a:alpha val="50000"/>
+          </a:schemeClr>
+        </a:solidFill>
+        <a:effectLst/>
+      </p:bgPr>
+    </p:bg>
+    <p:spTree>
+      <p:nvGrpSpPr>
+        <p:cNvPr id="1" name="">
+          <a:extLst>
+            <a:ext uri="{FF2B5EF4-FFF2-40B4-BE49-F238E27FC236}">
+              <a16:creationId xmlns:a16="http://schemas.microsoft.com/office/drawing/2014/main" id="{F09A9204-5AF3-A770-9347-C46831C6BD9E}"/>
+            </a:ext>
+          </a:extLst>
+        </p:cNvPr>
+        <p:cNvGrpSpPr/>
+        <p:nvPr/>
+      </p:nvGrpSpPr>
+      <p:grpSpPr>
+        <a:xfrm>
+          <a:off x="0" y="0"/>
+          <a:ext cx="0" cy="0"/>
+          <a:chOff x="0" y="0"/>
+          <a:chExt cx="0" cy="0"/>
+        </a:xfrm>
+      </p:grpSpPr>
+      <p:sp>
+        <p:nvSpPr>
+          <p:cNvPr id="2" name="Title 1">
+            <a:extLst>
+              <a:ext uri="{FF2B5EF4-FFF2-40B4-BE49-F238E27FC236}">
+                <a16:creationId xmlns:a16="http://schemas.microsoft.com/office/drawing/2014/main" id="{0ED4B50F-8CE7-6C6E-697E-108084F7F21E}"/>
+              </a:ext>
+            </a:extLst>
+          </p:cNvPr>
+          <p:cNvSpPr>
+            <a:spLocks noGrp="1"/>
+          </p:cNvSpPr>
+          <p:nvPr>
+            <p:ph type="title"/>
+          </p:nvPr>
+        </p:nvSpPr>
+        <p:spPr>
+          <a:xfrm>
+            <a:off x="1981200" y="365125"/>
+            <a:ext cx="9000000" cy="1325563"/>
+          </a:xfrm>
+        </p:spPr>
+        <p:txBody>
+          <a:bodyPr/>
+          <a:lstStyle/>
+          <a:p>
+            <a:r>
+              <a:rPr lang="en-US" b="1" dirty="0">
+                <a:latin typeface="Norse" pitchFamily="50" charset="0"/>
+              </a:rPr>
+              <a:t>Postcard design</a:t>
+            </a:r>
+            <a:endParaRPr lang="en-CA" b="1" dirty="0">
+              <a:latin typeface="Norse" pitchFamily="50" charset="0"/>
+            </a:endParaRPr>
+          </a:p>
+        </p:txBody>
+      </p:sp>
+      <p:pic>
+        <p:nvPicPr>
+          <p:cNvPr id="5" name="Graphic 4" descr="Lights On with solid fill">
+            <a:extLst>
+              <a:ext uri="{FF2B5EF4-FFF2-40B4-BE49-F238E27FC236}">
+                <a16:creationId xmlns:a16="http://schemas.microsoft.com/office/drawing/2014/main" id="{8F7883DA-B5AB-9CBE-E269-4AEB1F272112}"/>
+              </a:ext>
+            </a:extLst>
+          </p:cNvPr>
+          <p:cNvPicPr>
+            <a:picLocks noChangeAspect="1"/>
+          </p:cNvPicPr>
+          <p:nvPr/>
+        </p:nvPicPr>
+        <p:blipFill>
+          <a:blip>
+            <a:extLst>
+              <a:ext uri="{96DAC541-7B7A-43D3-8B79-37D633B846F1}">
+                <asvg:svgBlip xmlns:asvg="http://schemas.microsoft.com/office/drawing/2016/SVG/main" r:embed="rId2"/>
+              </a:ext>
+            </a:extLst>
+          </a:blip>
+          <a:stretch>
+            <a:fillRect/>
+          </a:stretch>
+        </p:blipFill>
+        <p:spPr>
+          <a:xfrm>
+            <a:off x="900000" y="360000"/>
+            <a:ext cx="914400" cy="914400"/>
+          </a:xfrm>
+          <a:prstGeom prst="rect">
+            <a:avLst/>
+          </a:prstGeom>
+        </p:spPr>
+      </p:pic>
+      <p:sp>
+        <p:nvSpPr>
+          <p:cNvPr id="6" name="Rectangle: Rounded Corners 5">
+            <a:extLst>
+              <a:ext uri="{FF2B5EF4-FFF2-40B4-BE49-F238E27FC236}">
+                <a16:creationId xmlns:a16="http://schemas.microsoft.com/office/drawing/2014/main" id="{FB3D84E7-D5BD-BD88-B0DA-66C0BF9059E7}"/>
+              </a:ext>
+            </a:extLst>
+          </p:cNvPr>
+          <p:cNvSpPr/>
+          <p:nvPr/>
+        </p:nvSpPr>
+        <p:spPr>
+          <a:xfrm>
+            <a:off x="1619249" y="1819275"/>
+            <a:ext cx="8620125" cy="4673600"/>
+          </a:xfrm>
+          <a:prstGeom prst="roundRect">
+            <a:avLst>
+              <a:gd name="adj" fmla="val 2808"/>
+            </a:avLst>
+          </a:prstGeom>
+          <a:noFill/>
+        </p:spPr>
+        <p:style>
+          <a:lnRef idx="2">
+            <a:schemeClr val="accent1">
+              <a:shade val="15000"/>
+            </a:schemeClr>
+          </a:lnRef>
+          <a:fillRef idx="1">
+            <a:schemeClr val="accent1"/>
+          </a:fillRef>
+          <a:effectRef idx="0">
+            <a:schemeClr val="accent1"/>
+          </a:effectRef>
+          <a:fontRef idx="minor">
+            <a:schemeClr val="lt1"/>
+          </a:fontRef>
+        </p:style>
+        <p:txBody>
+          <a:bodyPr rtlCol="0" anchor="ctr"/>
+          <a:lstStyle/>
+          <a:p>
+            <a:pPr algn="ctr"/>
+            <a:endParaRPr lang="en-CA"/>
+          </a:p>
+        </p:txBody>
+      </p:sp>
+      <p:sp>
+        <p:nvSpPr>
+          <p:cNvPr id="11" name="Rectangle 10">
+            <a:extLst>
+              <a:ext uri="{FF2B5EF4-FFF2-40B4-BE49-F238E27FC236}">
+                <a16:creationId xmlns:a16="http://schemas.microsoft.com/office/drawing/2014/main" id="{E219DC44-E02F-BC7F-00AD-641D1C6F6957}"/>
+              </a:ext>
+            </a:extLst>
+          </p:cNvPr>
+          <p:cNvSpPr/>
+          <p:nvPr/>
+        </p:nvSpPr>
+        <p:spPr>
+          <a:xfrm>
+            <a:off x="6191250" y="2076450"/>
+            <a:ext cx="3848095" cy="1952625"/>
+          </a:xfrm>
+          <a:prstGeom prst="rect">
+            <a:avLst/>
+          </a:prstGeom>
+        </p:spPr>
+        <p:style>
+          <a:lnRef idx="2">
+            <a:schemeClr val="accent1">
+              <a:shade val="15000"/>
+            </a:schemeClr>
+          </a:lnRef>
+          <a:fillRef idx="1">
+            <a:schemeClr val="accent1"/>
+          </a:fillRef>
+          <a:effectRef idx="0">
+            <a:schemeClr val="accent1"/>
+          </a:effectRef>
+          <a:fontRef idx="minor">
+            <a:schemeClr val="lt1"/>
+          </a:fontRef>
+        </p:style>
+        <p:txBody>
+          <a:bodyPr rtlCol="0" anchor="ctr"/>
+          <a:lstStyle/>
+          <a:p>
+            <a:pPr algn="ctr"/>
+            <a:r>
+              <a:rPr lang="en-CA" dirty="0"/>
+              <a:t>Address</a:t>
+            </a:r>
+          </a:p>
+        </p:txBody>
+      </p:sp>
+      <p:sp>
+        <p:nvSpPr>
+          <p:cNvPr id="7" name="Rectangle: Rounded Corners 6">
+            <a:extLst>
+              <a:ext uri="{FF2B5EF4-FFF2-40B4-BE49-F238E27FC236}">
+                <a16:creationId xmlns:a16="http://schemas.microsoft.com/office/drawing/2014/main" id="{ADE28956-0154-FF55-C918-E563E2608C51}"/>
+              </a:ext>
+            </a:extLst>
+          </p:cNvPr>
+          <p:cNvSpPr/>
+          <p:nvPr/>
+        </p:nvSpPr>
+        <p:spPr>
+          <a:xfrm>
+            <a:off x="8924920" y="2076449"/>
+            <a:ext cx="1114425" cy="1247775"/>
+          </a:xfrm>
+          <a:prstGeom prst="roundRect">
+            <a:avLst/>
+          </a:prstGeom>
+        </p:spPr>
+        <p:style>
+          <a:lnRef idx="2">
+            <a:schemeClr val="accent1">
+              <a:shade val="15000"/>
+            </a:schemeClr>
+          </a:lnRef>
+          <a:fillRef idx="1">
+            <a:schemeClr val="accent1"/>
+          </a:fillRef>
+          <a:effectRef idx="0">
+            <a:schemeClr val="accent1"/>
+          </a:effectRef>
+          <a:fontRef idx="minor">
+            <a:schemeClr val="lt1"/>
+          </a:fontRef>
+        </p:style>
+        <p:txBody>
+          <a:bodyPr rtlCol="0" anchor="ctr"/>
+          <a:lstStyle/>
+          <a:p>
+            <a:pPr algn="ctr"/>
+            <a:r>
+              <a:rPr lang="en-CA" dirty="0"/>
+              <a:t>Stamp</a:t>
+            </a:r>
+          </a:p>
+        </p:txBody>
+      </p:sp>
+      <p:cxnSp>
+        <p:nvCxnSpPr>
+          <p:cNvPr id="9" name="Straight Connector 8">
+            <a:extLst>
+              <a:ext uri="{FF2B5EF4-FFF2-40B4-BE49-F238E27FC236}">
+                <a16:creationId xmlns:a16="http://schemas.microsoft.com/office/drawing/2014/main" id="{A1D0C296-144D-E644-B74C-FFD5D524572C}"/>
+              </a:ext>
+            </a:extLst>
+          </p:cNvPr>
+          <p:cNvCxnSpPr>
+            <a:cxnSpLocks/>
+            <a:stCxn id="6" idx="0"/>
+            <a:endCxn id="6" idx="2"/>
+          </p:cNvCxnSpPr>
+          <p:nvPr/>
+        </p:nvCxnSpPr>
+        <p:spPr>
+          <a:xfrm>
+            <a:off x="5929312" y="1819275"/>
+            <a:ext cx="0" cy="4673600"/>
+          </a:xfrm>
+          <a:prstGeom prst="line">
+            <a:avLst/>
+          </a:prstGeom>
+        </p:spPr>
+        <p:style>
+          <a:lnRef idx="2">
+            <a:schemeClr val="accent1"/>
+          </a:lnRef>
+          <a:fillRef idx="0">
+            <a:schemeClr val="accent1"/>
+          </a:fillRef>
+          <a:effectRef idx="1">
+            <a:schemeClr val="accent1"/>
+          </a:effectRef>
+          <a:fontRef idx="minor">
+            <a:schemeClr val="tx1"/>
+          </a:fontRef>
+        </p:style>
+      </p:cxnSp>
+      <p:sp>
+        <p:nvSpPr>
+          <p:cNvPr id="13" name="Rectangle 12">
+            <a:extLst>
+              <a:ext uri="{FF2B5EF4-FFF2-40B4-BE49-F238E27FC236}">
+                <a16:creationId xmlns:a16="http://schemas.microsoft.com/office/drawing/2014/main" id="{EDD44461-0FB6-A20B-F1C8-1D1A54113A3B}"/>
+              </a:ext>
+            </a:extLst>
+          </p:cNvPr>
+          <p:cNvSpPr/>
+          <p:nvPr/>
+        </p:nvSpPr>
+        <p:spPr>
+          <a:xfrm>
+            <a:off x="6191249" y="4284662"/>
+            <a:ext cx="3848095" cy="1952625"/>
+          </a:xfrm>
+          <a:prstGeom prst="rect">
+            <a:avLst/>
+          </a:prstGeom>
+        </p:spPr>
+        <p:style>
+          <a:lnRef idx="2">
+            <a:schemeClr val="accent1">
+              <a:shade val="15000"/>
+            </a:schemeClr>
+          </a:lnRef>
+          <a:fillRef idx="1">
+            <a:schemeClr val="accent1"/>
+          </a:fillRef>
+          <a:effectRef idx="0">
+            <a:schemeClr val="accent1"/>
+          </a:effectRef>
+          <a:fontRef idx="minor">
+            <a:schemeClr val="lt1"/>
+          </a:fontRef>
+        </p:style>
+        <p:txBody>
+          <a:bodyPr rtlCol="0" anchor="ctr"/>
+          <a:lstStyle/>
+          <a:p>
+            <a:pPr algn="ctr"/>
+            <a:r>
+              <a:rPr lang="en-CA" dirty="0"/>
+              <a:t>Fun fact</a:t>
+            </a:r>
+          </a:p>
+        </p:txBody>
+      </p:sp>
+      <p:sp>
+        <p:nvSpPr>
+          <p:cNvPr id="15" name="Rectangle 14">
+            <a:extLst>
+              <a:ext uri="{FF2B5EF4-FFF2-40B4-BE49-F238E27FC236}">
+                <a16:creationId xmlns:a16="http://schemas.microsoft.com/office/drawing/2014/main" id="{3E44E5BE-E4EC-B81F-15C2-3326703DB0C9}"/>
+              </a:ext>
+            </a:extLst>
+          </p:cNvPr>
+          <p:cNvSpPr/>
+          <p:nvPr/>
+        </p:nvSpPr>
+        <p:spPr>
+          <a:xfrm>
+            <a:off x="1850233" y="2076450"/>
+            <a:ext cx="3848095" cy="4160837"/>
+          </a:xfrm>
+          <a:prstGeom prst="rect">
+            <a:avLst/>
+          </a:prstGeom>
+        </p:spPr>
+        <p:style>
+          <a:lnRef idx="2">
+            <a:schemeClr val="accent1">
+              <a:shade val="15000"/>
+            </a:schemeClr>
+          </a:lnRef>
+          <a:fillRef idx="1">
+            <a:schemeClr val="accent1"/>
+          </a:fillRef>
+          <a:effectRef idx="0">
+            <a:schemeClr val="accent1"/>
+          </a:effectRef>
+          <a:fontRef idx="minor">
+            <a:schemeClr val="lt1"/>
+          </a:fontRef>
+        </p:style>
+        <p:txBody>
+          <a:bodyPr rtlCol="0" anchor="ctr"/>
+          <a:lstStyle/>
+          <a:p>
+            <a:pPr algn="ctr"/>
+            <a:r>
+              <a:rPr lang="en-CA"/>
+              <a:t>Handwritten note</a:t>
+            </a:r>
+            <a:endParaRPr lang="en-CA" dirty="0"/>
+          </a:p>
+        </p:txBody>
+      </p:sp>
+    </p:spTree>
+    <p:extLst>
+      <p:ext uri="{BB962C8B-B14F-4D97-AF65-F5344CB8AC3E}">
+        <p14:creationId xmlns:p14="http://schemas.microsoft.com/office/powerpoint/2010/main" val="1415035642"/>
       </p:ext>
     </p:extLst>
   </p:cSld>

</xml_diff>